<commit_message>
Sunuma Platformlar & Indirme slaydi eklendi (v1.0.0 GitHub Releases)
Tanitim sunumuna Windows 10/11 (x64) + macOS (Apple Silicon) platform
bilgisi ve github.com/Azizsekerdil/smart-van-sales-management-system
Releases (v1.0.0) indirme baglantisi iceren yeni bir slayt eklendi;
macOS paketinin notarize edilmedigi dipnotu (sag tik -> Ac) belirtildi.
TR/EN tum ciktilar (pptx/pdf/html + baski surumleri) yeniden uretildi.

Co-Authored-By: Claude Fable 5 <noreply@anthropic.com>
</commit_message>
<xml_diff>
--- a/docs/presentation/Van_Sales_Intro_EN_PUBLIC.pptx
+++ b/docs/presentation/Van_Sales_Intro_EN_PUBLIC.pptx
@@ -37,6 +37,7 @@
     <p:sldId id="285" r:id="rId36"/>
     <p:sldId id="286" r:id="rId37"/>
     <p:sldId id="287" r:id="rId38"/>
+    <p:sldId id="288" r:id="rId39"/>
   </p:sldIdLst>
   <p:sldSz cx="12191695" cy="6858000" type="screen4x3"/>
   <p:notesSz cx="6858000" cy="9144000"/>
@@ -3857,7 +3858,7 @@
                 </a:solidFill>
                 <a:latin typeface="DejaVu Sans"/>
               </a:rPr>
-              <a:t>v1.0.0   10 / 32</a:t>
+              <a:t>v1.0.0   10 / 33</a:t>
             </a:r>
           </a:p>
         </p:txBody>
@@ -4181,7 +4182,7 @@
                 </a:solidFill>
                 <a:latin typeface="DejaVu Sans"/>
               </a:rPr>
-              <a:t>v1.0.0   11 / 32</a:t>
+              <a:t>v1.0.0   11 / 33</a:t>
             </a:r>
           </a:p>
         </p:txBody>
@@ -5175,7 +5176,7 @@
                 </a:solidFill>
                 <a:latin typeface="DejaVu Sans"/>
               </a:rPr>
-              <a:t>v1.0.0   12 / 32</a:t>
+              <a:t>v1.0.0   12 / 33</a:t>
             </a:r>
           </a:p>
         </p:txBody>
@@ -5271,7 +5272,7 @@
                 </a:solidFill>
                 <a:latin typeface="DejaVu Sans"/>
               </a:rPr>
-              <a:t>v1.0.0   13 / 32</a:t>
+              <a:t>v1.0.0   13 / 33</a:t>
             </a:r>
           </a:p>
         </p:txBody>
@@ -6111,7 +6112,7 @@
                 </a:solidFill>
                 <a:latin typeface="DejaVu Sans"/>
               </a:rPr>
-              <a:t>v1.0.0   14 / 32</a:t>
+              <a:t>v1.0.0   14 / 33</a:t>
             </a:r>
           </a:p>
         </p:txBody>
@@ -6526,7 +6527,7 @@
                 </a:solidFill>
                 <a:latin typeface="DejaVu Sans"/>
               </a:rPr>
-              <a:t>v1.0.0   15 / 32</a:t>
+              <a:t>v1.0.0   15 / 33</a:t>
             </a:r>
           </a:p>
         </p:txBody>
@@ -6862,7 +6863,7 @@
                 </a:solidFill>
                 <a:latin typeface="DejaVu Sans"/>
               </a:rPr>
-              <a:t>v1.0.0   16 / 32</a:t>
+              <a:t>v1.0.0   16 / 33</a:t>
             </a:r>
           </a:p>
         </p:txBody>
@@ -7856,7 +7857,7 @@
                 </a:solidFill>
                 <a:latin typeface="DejaVu Sans"/>
               </a:rPr>
-              <a:t>v1.0.0   17 / 32</a:t>
+              <a:t>v1.0.0   17 / 33</a:t>
             </a:r>
           </a:p>
         </p:txBody>
@@ -7952,7 +7953,7 @@
                 </a:solidFill>
                 <a:latin typeface="DejaVu Sans"/>
               </a:rPr>
-              <a:t>v1.0.0   18 / 32</a:t>
+              <a:t>v1.0.0   18 / 33</a:t>
             </a:r>
           </a:p>
         </p:txBody>
@@ -8792,7 +8793,7 @@
                 </a:solidFill>
                 <a:latin typeface="DejaVu Sans"/>
               </a:rPr>
-              <a:t>v1.0.0   19 / 32</a:t>
+              <a:t>v1.0.0   19 / 33</a:t>
             </a:r>
           </a:p>
         </p:txBody>
@@ -9191,7 +9192,7 @@
                 </a:solidFill>
                 <a:latin typeface="DejaVu Sans"/>
               </a:rPr>
-              <a:t>v1.0.0   02 / 32</a:t>
+              <a:t>v1.0.0   02 / 33</a:t>
             </a:r>
           </a:p>
         </p:txBody>
@@ -9600,7 +9601,7 @@
                 </a:solidFill>
                 <a:latin typeface="DejaVu Sans"/>
               </a:rPr>
-              <a:t>v1.0.0   20 / 32</a:t>
+              <a:t>v1.0.0   20 / 33</a:t>
             </a:r>
           </a:p>
         </p:txBody>
@@ -9696,7 +9697,7 @@
                 </a:solidFill>
                 <a:latin typeface="DejaVu Sans"/>
               </a:rPr>
-              <a:t>v1.0.0   21 / 32</a:t>
+              <a:t>v1.0.0   21 / 33</a:t>
             </a:r>
           </a:p>
         </p:txBody>
@@ -10536,7 +10537,7 @@
                 </a:solidFill>
                 <a:latin typeface="DejaVu Sans"/>
               </a:rPr>
-              <a:t>v1.0.0   22 / 32</a:t>
+              <a:t>v1.0.0   22 / 33</a:t>
             </a:r>
           </a:p>
         </p:txBody>
@@ -11376,7 +11377,7 @@
                 </a:solidFill>
                 <a:latin typeface="DejaVu Sans"/>
               </a:rPr>
-              <a:t>v1.0.0   23 / 32</a:t>
+              <a:t>v1.0.0   23 / 33</a:t>
             </a:r>
           </a:p>
         </p:txBody>
@@ -11929,7 +11930,7 @@
                 </a:solidFill>
                 <a:latin typeface="DejaVu Sans"/>
               </a:rPr>
-              <a:t>v1.0.0   24 / 32</a:t>
+              <a:t>v1.0.0   24 / 33</a:t>
             </a:r>
           </a:p>
         </p:txBody>
@@ -12025,7 +12026,7 @@
                 </a:solidFill>
                 <a:latin typeface="DejaVu Sans"/>
               </a:rPr>
-              <a:t>v1.0.0   25 / 32</a:t>
+              <a:t>v1.0.0   25 / 33</a:t>
             </a:r>
           </a:p>
         </p:txBody>
@@ -12865,7 +12866,7 @@
                 </a:solidFill>
                 <a:latin typeface="DejaVu Sans"/>
               </a:rPr>
-              <a:t>v1.0.0   26 / 32</a:t>
+              <a:t>v1.0.0   26 / 33</a:t>
             </a:r>
           </a:p>
         </p:txBody>
@@ -13705,7 +13706,7 @@
                 </a:solidFill>
                 <a:latin typeface="DejaVu Sans"/>
               </a:rPr>
-              <a:t>v1.0.0   27 / 32</a:t>
+              <a:t>v1.0.0   27 / 33</a:t>
             </a:r>
           </a:p>
         </p:txBody>
@@ -14104,7 +14105,7 @@
                 </a:solidFill>
                 <a:latin typeface="DejaVu Sans"/>
               </a:rPr>
-              <a:t>v1.0.0   28 / 32</a:t>
+              <a:t>v1.0.0   28 / 33</a:t>
             </a:r>
           </a:p>
         </p:txBody>
@@ -14944,7 +14945,7 @@
                 </a:solidFill>
                 <a:latin typeface="DejaVu Sans"/>
               </a:rPr>
-              <a:t>v1.0.0   29 / 32</a:t>
+              <a:t>v1.0.0   29 / 33</a:t>
             </a:r>
           </a:p>
         </p:txBody>
@@ -15343,7 +15344,7 @@
                 </a:solidFill>
                 <a:latin typeface="DejaVu Sans"/>
               </a:rPr>
-              <a:t>v1.0.0   03 / 32</a:t>
+              <a:t>v1.0.0   03 / 33</a:t>
             </a:r>
           </a:p>
         </p:txBody>
@@ -16183,7 +16184,7 @@
                 </a:solidFill>
                 <a:latin typeface="DejaVu Sans"/>
               </a:rPr>
-              <a:t>v1.0.0   30 / 32</a:t>
+              <a:t>v1.0.0   30 / 33</a:t>
             </a:r>
           </a:p>
         </p:txBody>
@@ -16997,7 +16998,7 @@
                 </a:solidFill>
                 <a:latin typeface="DejaVu Sans"/>
               </a:rPr>
-              <a:t>v1.0.0   31 / 32</a:t>
+              <a:t>v1.0.0   31 / 33</a:t>
             </a:r>
           </a:p>
         </p:txBody>
@@ -17586,6 +17587,342 @@
       <p:grpSpPr/>
       <p:sp>
         <p:nvSpPr>
+          <p:cNvPr id="2" name="TextBox 1"/>
+          <p:cNvSpPr txBox="1"/>
+          <p:nvPr/>
+        </p:nvSpPr>
+        <p:spPr>
+          <a:xfrm>
+            <a:off x="566928" y="310896"/>
+            <a:ext cx="7315200" cy="274320"/>
+          </a:xfrm>
+          <a:prstGeom prst="rect">
+            <a:avLst/>
+          </a:prstGeom>
+          <a:noFill/>
+        </p:spPr>
+        <p:txBody>
+          <a:bodyPr wrap="square" lIns="0" rIns="0" tIns="0" bIns="0" anchor="t">
+            <a:spAutoFit/>
+          </a:bodyPr>
+          <a:lstStyle/>
+          <a:p>
+            <a:pPr algn="l"/>
+            <a:r>
+              <a:rPr sz="1000" b="1">
+                <a:solidFill>
+                  <a:srgbClr val="64748B"/>
+                </a:solidFill>
+                <a:latin typeface="DejaVu Sans"/>
+              </a:rPr>
+              <a:t>SMART VAN SALES MANAGEMENT SYSTEM</a:t>
+            </a:r>
+          </a:p>
+        </p:txBody>
+      </p:sp>
+      <p:sp>
+        <p:nvSpPr>
+          <p:cNvPr id="3" name="TextBox 2"/>
+          <p:cNvSpPr txBox="1"/>
+          <p:nvPr/>
+        </p:nvSpPr>
+        <p:spPr>
+          <a:xfrm>
+            <a:off x="9326880" y="310896"/>
+            <a:ext cx="2286000" cy="274320"/>
+          </a:xfrm>
+          <a:prstGeom prst="rect">
+            <a:avLst/>
+          </a:prstGeom>
+          <a:noFill/>
+        </p:spPr>
+        <p:txBody>
+          <a:bodyPr wrap="square" lIns="0" rIns="0" tIns="0" bIns="0" anchor="t">
+            <a:spAutoFit/>
+          </a:bodyPr>
+          <a:lstStyle/>
+          <a:p>
+            <a:pPr algn="r"/>
+            <a:r>
+              <a:rPr sz="1000" b="0">
+                <a:solidFill>
+                  <a:srgbClr val="64748B"/>
+                </a:solidFill>
+                <a:latin typeface="DejaVu Sans"/>
+              </a:rPr>
+              <a:t>v1.0.0   32 / 33</a:t>
+            </a:r>
+          </a:p>
+        </p:txBody>
+      </p:sp>
+      <p:sp>
+        <p:nvSpPr>
+          <p:cNvPr id="4" name="Rectangle 3"/>
+          <p:cNvSpPr/>
+          <p:nvPr/>
+        </p:nvSpPr>
+        <p:spPr>
+          <a:xfrm>
+            <a:off x="566928" y="621792"/>
+            <a:ext cx="11064240" cy="12801"/>
+          </a:xfrm>
+          <a:prstGeom prst="rect">
+            <a:avLst/>
+          </a:prstGeom>
+          <a:solidFill>
+            <a:srgbClr val="334155"/>
+          </a:solidFill>
+          <a:ln>
+            <a:noFill/>
+          </a:ln>
+          <a:effectLst/>
+        </p:spPr>
+        <p:style>
+          <a:lnRef idx="1">
+            <a:schemeClr val="accent1"/>
+          </a:lnRef>
+          <a:fillRef idx="3">
+            <a:schemeClr val="accent1"/>
+          </a:fillRef>
+          <a:effectRef idx="2">
+            <a:schemeClr val="accent1"/>
+          </a:effectRef>
+          <a:fontRef idx="minor">
+            <a:schemeClr val="lt1"/>
+          </a:fontRef>
+        </p:style>
+        <p:txBody>
+          <a:bodyPr rtlCol="0" anchor="ctr"/>
+          <a:lstStyle/>
+          <a:p/>
+        </p:txBody>
+      </p:sp>
+      <p:sp>
+        <p:nvSpPr>
+          <p:cNvPr id="5" name="TextBox 4"/>
+          <p:cNvSpPr txBox="1"/>
+          <p:nvPr/>
+        </p:nvSpPr>
+        <p:spPr>
+          <a:xfrm>
+            <a:off x="566928" y="1188720"/>
+            <a:ext cx="10424160" cy="320040"/>
+          </a:xfrm>
+          <a:prstGeom prst="rect">
+            <a:avLst/>
+          </a:prstGeom>
+          <a:noFill/>
+        </p:spPr>
+        <p:txBody>
+          <a:bodyPr wrap="square" lIns="0" rIns="0" tIns="0" bIns="0" anchor="t">
+            <a:spAutoFit/>
+          </a:bodyPr>
+          <a:lstStyle/>
+          <a:p>
+            <a:pPr algn="l"/>
+            <a:r>
+              <a:rPr sz="1100" b="1">
+                <a:solidFill>
+                  <a:srgbClr val="2DD4BF"/>
+                </a:solidFill>
+                <a:latin typeface="DejaVu Sans"/>
+              </a:rPr>
+              <a:t>PLATFORMS &amp; DOWNLOAD</a:t>
+            </a:r>
+          </a:p>
+        </p:txBody>
+      </p:sp>
+      <p:sp>
+        <p:nvSpPr>
+          <p:cNvPr id="6" name="TextBox 5"/>
+          <p:cNvSpPr txBox="1"/>
+          <p:nvPr/>
+        </p:nvSpPr>
+        <p:spPr>
+          <a:xfrm>
+            <a:off x="566928" y="1645920"/>
+            <a:ext cx="10424160" cy="1371600"/>
+          </a:xfrm>
+          <a:prstGeom prst="rect">
+            <a:avLst/>
+          </a:prstGeom>
+          <a:noFill/>
+        </p:spPr>
+        <p:txBody>
+          <a:bodyPr wrap="square" lIns="0" rIns="0" tIns="0" bIns="0" anchor="t">
+            <a:spAutoFit/>
+          </a:bodyPr>
+          <a:lstStyle/>
+          <a:p>
+            <a:pPr algn="l"/>
+            <a:r>
+              <a:rPr sz="3600" b="1">
+                <a:solidFill>
+                  <a:srgbClr val="FFFFFF"/>
+                </a:solidFill>
+                <a:latin typeface="DejaVu Sans"/>
+              </a:rPr>
+              <a:t>Windows 10/11 (x64) &amp; macOS (Apple Silicon)</a:t>
+            </a:r>
+          </a:p>
+        </p:txBody>
+      </p:sp>
+      <p:sp>
+        <p:nvSpPr>
+          <p:cNvPr id="7" name="Rounded Rectangle 6"/>
+          <p:cNvSpPr/>
+          <p:nvPr/>
+        </p:nvSpPr>
+        <p:spPr>
+          <a:xfrm>
+            <a:off x="566928" y="3246120"/>
+            <a:ext cx="11064240" cy="1133856"/>
+          </a:xfrm>
+          <a:prstGeom prst="roundRect">
+            <a:avLst>
+              <a:gd name="adj" fmla="val 6000"/>
+            </a:avLst>
+          </a:prstGeom>
+          <a:solidFill>
+            <a:srgbClr val="1E293B"/>
+          </a:solidFill>
+          <a:ln w="12700">
+            <a:solidFill>
+              <a:srgbClr val="4F46E5"/>
+            </a:solidFill>
+          </a:ln>
+          <a:effectLst/>
+        </p:spPr>
+        <p:style>
+          <a:lnRef idx="1">
+            <a:schemeClr val="accent1"/>
+          </a:lnRef>
+          <a:fillRef idx="3">
+            <a:schemeClr val="accent1"/>
+          </a:fillRef>
+          <a:effectRef idx="2">
+            <a:schemeClr val="accent1"/>
+          </a:effectRef>
+          <a:fontRef idx="minor">
+            <a:schemeClr val="lt1"/>
+          </a:fontRef>
+        </p:style>
+        <p:txBody>
+          <a:bodyPr rtlCol="0" anchor="ctr"/>
+          <a:lstStyle/>
+          <a:p/>
+        </p:txBody>
+      </p:sp>
+      <p:sp>
+        <p:nvSpPr>
+          <p:cNvPr id="8" name="TextBox 7"/>
+          <p:cNvSpPr txBox="1"/>
+          <p:nvPr/>
+        </p:nvSpPr>
+        <p:spPr>
+          <a:xfrm>
+            <a:off x="896112" y="3483863"/>
+            <a:ext cx="10424160" cy="676656"/>
+          </a:xfrm>
+          <a:prstGeom prst="rect">
+            <a:avLst/>
+          </a:prstGeom>
+          <a:noFill/>
+        </p:spPr>
+        <p:txBody>
+          <a:bodyPr wrap="square" lIns="0" rIns="0" tIns="0" bIns="0" anchor="t">
+            <a:spAutoFit/>
+          </a:bodyPr>
+          <a:lstStyle/>
+          <a:p>
+            <a:pPr algn="l"/>
+            <a:r>
+              <a:rPr sz="1600" b="1">
+                <a:solidFill>
+                  <a:srgbClr val="2DD4BF"/>
+                </a:solidFill>
+                <a:latin typeface="DejaVu Sans"/>
+              </a:rPr>
+              <a:t>Download: GitHub Releases (v1.0.0)</a:t>
+            </a:r>
+          </a:p>
+          <a:p>
+            <a:pPr algn="l"/>
+            <a:r>
+              <a:rPr sz="1600" b="1">
+                <a:solidFill>
+                  <a:srgbClr val="2DD4BF"/>
+                </a:solidFill>
+                <a:latin typeface="DejaVu Sans"/>
+              </a:rPr>
+              <a:t>github.com/Azizsekerdil/smart-van-sales-management-system/releases</a:t>
+            </a:r>
+          </a:p>
+        </p:txBody>
+      </p:sp>
+      <p:sp>
+        <p:nvSpPr>
+          <p:cNvPr id="9" name="TextBox 8"/>
+          <p:cNvSpPr txBox="1"/>
+          <p:nvPr/>
+        </p:nvSpPr>
+        <p:spPr>
+          <a:xfrm>
+            <a:off x="566928" y="4764024"/>
+            <a:ext cx="10058400" cy="1371600"/>
+          </a:xfrm>
+          <a:prstGeom prst="rect">
+            <a:avLst/>
+          </a:prstGeom>
+          <a:noFill/>
+        </p:spPr>
+        <p:txBody>
+          <a:bodyPr wrap="square" lIns="0" rIns="0" tIns="0" bIns="0" anchor="t">
+            <a:spAutoFit/>
+          </a:bodyPr>
+          <a:lstStyle/>
+          <a:p>
+            <a:pPr algn="l"/>
+            <a:r>
+              <a:rPr sz="1400" b="0">
+                <a:solidFill>
+                  <a:srgbClr val="94A3B8"/>
+                </a:solidFill>
+                <a:latin typeface="DejaVu Sans"/>
+              </a:rPr>
+              <a:t>Two assets are published on GitHub Releases: a Windows zip and a macOS zip. The macOS package targets Apple Silicon (arm64) and is not notarized — on first launch, right-click → Open.</a:t>
+            </a:r>
+          </a:p>
+        </p:txBody>
+      </p:sp>
+    </p:spTree>
+  </p:cSld>
+  <p:clrMapOvr>
+    <a:masterClrMapping/>
+  </p:clrMapOvr>
+</p:sld>
+</file>
+
+<file path=ppt/slides/slide33.xml><?xml version="1.0" encoding="utf-8"?>
+<p:sld xmlns:a="http://schemas.openxmlformats.org/drawingml/2006/main" xmlns:p="http://schemas.openxmlformats.org/presentationml/2006/main" xmlns:r="http://schemas.openxmlformats.org/officeDocument/2006/relationships">
+  <p:cSld>
+    <p:bg>
+      <p:bgPr>
+        <a:solidFill>
+          <a:srgbClr val="0F172A"/>
+        </a:solidFill>
+        <a:effectLst/>
+      </p:bgPr>
+    </p:bg>
+    <p:spTree>
+      <p:nvGrpSpPr>
+        <p:cNvPr id="1" name=""/>
+        <p:cNvGrpSpPr/>
+        <p:nvPr/>
+      </p:nvGrpSpPr>
+      <p:grpSpPr/>
+      <p:sp>
+        <p:nvSpPr>
           <p:cNvPr id="2" name="Rectangle 1"/>
           <p:cNvSpPr/>
           <p:nvPr/>
@@ -18142,7 +18479,7 @@
                 </a:solidFill>
                 <a:latin typeface="DejaVu Sans"/>
               </a:rPr>
-              <a:t>v1.0.0   04 / 32</a:t>
+              <a:t>v1.0.0   04 / 33</a:t>
             </a:r>
           </a:p>
         </p:txBody>
@@ -19904,7 +20241,7 @@
                 </a:solidFill>
                 <a:latin typeface="DejaVu Sans"/>
               </a:rPr>
-              <a:t>v1.0.0   05 / 32</a:t>
+              <a:t>v1.0.0   05 / 33</a:t>
             </a:r>
           </a:p>
         </p:txBody>
@@ -21040,7 +21377,7 @@
                 </a:solidFill>
                 <a:latin typeface="DejaVu Sans"/>
               </a:rPr>
-              <a:t>v1.0.0   06 / 32</a:t>
+              <a:t>v1.0.0   06 / 33</a:t>
             </a:r>
           </a:p>
         </p:txBody>
@@ -21468,7 +21805,7 @@
                 </a:solidFill>
                 <a:latin typeface="DejaVu Sans"/>
               </a:rPr>
-              <a:t>v1.0.0   07 / 32</a:t>
+              <a:t>v1.0.0   07 / 33</a:t>
             </a:r>
           </a:p>
         </p:txBody>
@@ -21564,7 +21901,7 @@
                 </a:solidFill>
                 <a:latin typeface="DejaVu Sans"/>
               </a:rPr>
-              <a:t>v1.0.0   08 / 32</a:t>
+              <a:t>v1.0.0   08 / 33</a:t>
             </a:r>
           </a:p>
         </p:txBody>
@@ -22720,7 +23057,7 @@
                 </a:solidFill>
                 <a:latin typeface="DejaVu Sans"/>
               </a:rPr>
-              <a:t>v1.0.0   09 / 32</a:t>
+              <a:t>v1.0.0   09 / 33</a:t>
             </a:r>
           </a:p>
         </p:txBody>

</xml_diff>